<commit_message>
feat(model): migrate model story to Qwen3.5 (0.4-9b / lite 4B) with settings auto-migration
Base moves to qwen3.5:9b (tantular-office:0.4-9b alias) and qwen3.5:4b lite; installers build the Office profile locally from the official base with registry as explicit opt-in; Studio timeout 480s. loadSettings now migrates EXACT retired defaults (0.3-8b -> 0.4-9b, qwen3:8b -> qwen3.5:9b, qwen3:4b -> tantular-office:lite) so earlier installs do not silently stay on old models, while custom model choices are never touched. MODEL_PERFORMANCE .md/.pptx/.docx regenerated for the 9B story; workshop dist rebuilt.

Co-Authored-By: Claude Fable 5 <noreply@anthropic.com>
</commit_message>
<xml_diff>
--- a/tantular_office_addin/docs/MODEL_PERFORMANCE.pptx
+++ b/tantular_office_addin/docs/MODEL_PERFORMANCE.pptx
@@ -3624,7 +3624,7 @@
                 </a:solidFill>
                 <a:latin typeface="Calibri"/>
               </a:rPr>
-              <a:t>• Each click sends ONE request with a 5-minute budget (timeoutMs: 300_000).</a:t>
+              <a:t>• Each click sends ONE request with an 8-minute budget (timeoutMs: 480_000).</a:t>
             </a:r>
           </a:p>
           <a:p>
@@ -3643,7 +3643,7 @@
                 </a:solidFill>
                 <a:latin typeface="Calibri"/>
               </a:rPr>
-              <a:t>• The 8B model can’t finish inside that budget on an under-provisioned laptop.</a:t>
+              <a:t>• The 9B model can’t finish inside that budget on an under-provisioned laptop.</a:t>
             </a:r>
           </a:p>
           <a:p>
@@ -3934,7 +3934,7 @@
                 </a:solidFill>
                 <a:latin typeface="Calibri"/>
               </a:rPr>
-              <a:t>• The 8B model is roughly 5 GB of weights.</a:t>
+              <a:t>• The 9B model is roughly 6.6 GB of weights.</a:t>
             </a:r>
           </a:p>
           <a:p>
@@ -4082,7 +4082,7 @@
                           </a:solidFill>
                           <a:latin typeface="Calibri"/>
                         </a:rPr>
-                        <a:t>8B model verdict</a:t>
+                        <a:t>9B model verdict</a:t>
                       </a:r>
                     </a:p>
                   </a:txBody>
@@ -4138,7 +4138,7 @@
                           </a:solidFill>
                           <a:latin typeface="Calibri"/>
                         </a:rPr>
-                        <a:t>Full 8B experience, works as designed</a:t>
+                        <a:t>Full 9B experience, works as designed</a:t>
                       </a:r>
                     </a:p>
                   </a:txBody>
@@ -4306,7 +4306,7 @@
                           </a:solidFill>
                           <a:latin typeface="Calibri"/>
                         </a:rPr>
-                        <a:t>Effectively unusable with 8B</a:t>
+                        <a:t>Effectively unusable with 9B</a:t>
                       </a:r>
                     </a:p>
                   </a:txBody>
@@ -4508,7 +4508,7 @@
                 </a:solidFill>
                 <a:latin typeface="Calibri"/>
               </a:rPr>
-              <a:t>• 2.  In a terminal / PowerShell:  ollama pull ghifidanukusumo/tantular:lite   (~2.5 GB)</a:t>
+              <a:t>• 2.  In the workshop folder: TANTULAR_OFFICE_BASE_MODEL=qwen3.5:4b TANTULAR_OFFICE_MODEL_NAME=tantular-office:lite npm run model:office</a:t>
             </a:r>
           </a:p>
           <a:p>
@@ -4527,7 +4527,7 @@
                 </a:solidFill>
                 <a:latin typeface="Calibri"/>
               </a:rPr>
-              <a:t>• 3.  Pane → Pengaturan model lokal → Model Studio = ghifidanukusumo/tantular:lite → Simpan → Tes.</a:t>
+              <a:t>• 3.  Pane → Pengaturan model lokal → Model Studio = tantular-office:lite → Simpan → Tes.</a:t>
             </a:r>
           </a:p>
           <a:p>
@@ -4675,7 +4675,7 @@
                 </a:solidFill>
                 <a:latin typeface="Calibri"/>
               </a:rPr>
-              <a:t>Installers pull the published model by RAM</a:t>
+              <a:t>Installers build the Office profile by RAM</a:t>
             </a:r>
           </a:p>
         </p:txBody>
@@ -4761,7 +4761,7 @@
                 </a:solidFill>
                 <a:latin typeface="Calibri"/>
               </a:rPr>
-              <a:t>• Model published at ollama.com/ghifidanukusumo/Tantular — installers just ollama pull.</a:t>
+              <a:t>• Installers pull the official Qwen3.5 base from Ollama and apply the local Office profile.</a:t>
             </a:r>
           </a:p>
           <a:p>
@@ -4799,7 +4799,7 @@
                 </a:solidFill>
                 <a:latin typeface="Calibri"/>
               </a:rPr>
-              <a:t>• Below 12 GB they pull the lite tag; offline venues fall back to local Modelfile build.</a:t>
+              <a:t>• Below 12 GB they skip the 9B and build the lite (4B) alias instead.</a:t>
             </a:r>
           </a:p>
         </p:txBody>
@@ -4823,10 +4823,9 @@
                 <a:tableStyleId>{5C22544A-7EE6-4342-B048-85BDC9FD1C3A}</a:tableStyleId>
               </a:tblPr>
               <a:tblGrid>
-                <a:gridCol w="2636443"/>
-                <a:gridCol w="2636443"/>
-                <a:gridCol w="2636443"/>
-                <a:gridCol w="2636446"/>
+                <a:gridCol w="3515258"/>
+                <a:gridCol w="3515258"/>
+                <a:gridCol w="3515259"/>
               </a:tblGrid>
               <a:tr h="347472">
                 <a:tc>
@@ -4873,34 +4872,7 @@
                           </a:solidFill>
                           <a:latin typeface="Calibri"/>
                         </a:rPr>
-                        <a:t>Tag pulled</a:t>
-                      </a:r>
-                    </a:p>
-                  </a:txBody>
-                  <a:tcPr marL="109728" marT="36576" marB="36576">
-                    <a:solidFill>
-                      <a:srgbClr val="F1EEE8"/>
-                    </a:solidFill>
-                  </a:tcPr>
-                </a:tc>
-                <a:tc>
-                  <a:txBody>
-                    <a:bodyPr/>
-                    <a:lstStyle/>
-                    <a:p>
-                      <a:pPr>
-                        <a:spcAft>
-                          <a:spcPts val="0"/>
-                        </a:spcAft>
-                      </a:pPr>
-                      <a:r>
-                        <a:rPr sz="1300" b="1">
-                          <a:solidFill>
-                            <a:srgbClr val="1A1A1E"/>
-                          </a:solidFill>
-                          <a:latin typeface="Calibri"/>
-                        </a:rPr>
-                        <a:t>Base</a:t>
+                        <a:t>Base pulled</a:t>
                       </a:r>
                     </a:p>
                   </a:txBody>
@@ -4983,7 +4955,7 @@
                           </a:solidFill>
                           <a:latin typeface="Calibri"/>
                         </a:rPr>
-                        <a:t>ghifidanukusumo/tantular:latest</a:t>
+                        <a:t>qwen3.5:9b</a:t>
                       </a:r>
                     </a:p>
                   </a:txBody>
@@ -5010,34 +4982,7 @@
                           </a:solidFill>
                           <a:latin typeface="Calibri"/>
                         </a:rPr>
-                        <a:t>qwen3:8b</a:t>
-                      </a:r>
-                    </a:p>
-                  </a:txBody>
-                  <a:tcPr marL="109728" marT="36576" marB="36576">
-                    <a:solidFill>
-                      <a:srgbClr val="FFFFFF"/>
-                    </a:solidFill>
-                  </a:tcPr>
-                </a:tc>
-                <a:tc>
-                  <a:txBody>
-                    <a:bodyPr/>
-                    <a:lstStyle/>
-                    <a:p>
-                      <a:pPr>
-                        <a:spcAft>
-                          <a:spcPts val="0"/>
-                        </a:spcAft>
-                      </a:pPr>
-                      <a:r>
-                        <a:rPr sz="1300" b="0">
-                          <a:solidFill>
-                            <a:srgbClr val="333338"/>
-                          </a:solidFill>
-                          <a:latin typeface="Calibri"/>
-                        </a:rPr>
-                        <a:t>tantular-office:0.3-8b</a:t>
+                        <a:t>tantular-office:0.4-9b</a:t>
                       </a:r>
                     </a:p>
                   </a:txBody>
@@ -5093,34 +5038,7 @@
                           </a:solidFill>
                           <a:latin typeface="Calibri"/>
                         </a:rPr>
-                        <a:t>ghifidanukusumo/tantular:lite</a:t>
-                      </a:r>
-                    </a:p>
-                  </a:txBody>
-                  <a:tcPr marL="109728" marT="36576" marB="36576">
-                    <a:solidFill>
-                      <a:srgbClr val="FFFFFF"/>
-                    </a:solidFill>
-                  </a:tcPr>
-                </a:tc>
-                <a:tc>
-                  <a:txBody>
-                    <a:bodyPr/>
-                    <a:lstStyle/>
-                    <a:p>
-                      <a:pPr>
-                        <a:spcAft>
-                          <a:spcPts val="0"/>
-                        </a:spcAft>
-                      </a:pPr>
-                      <a:r>
-                        <a:rPr sz="1300" b="0">
-                          <a:solidFill>
-                            <a:srgbClr val="333338"/>
-                          </a:solidFill>
-                          <a:latin typeface="Calibri"/>
-                        </a:rPr>
-                        <a:t>qwen3:4b</a:t>
+                        <a:t>qwen3.5:4b</a:t>
                       </a:r>
                     </a:p>
                   </a:txBody>
@@ -5486,7 +5404,7 @@
                           </a:solidFill>
                           <a:latin typeface="Calibri"/>
                         </a:rPr>
-                        <a:t>300 s</a:t>
+                        <a:t>480 s</a:t>
                       </a:r>
                     </a:p>
                   </a:txBody>
@@ -5513,7 +5431,7 @@
                           </a:solidFill>
                           <a:latin typeface="Calibri"/>
                         </a:rPr>
-                        <a:t>Model Studio (8B / lite)</a:t>
+                        <a:t>Model Studio (9B / lite)</a:t>
                       </a:r>
                     </a:p>
                   </a:txBody>
@@ -5901,7 +5819,7 @@
                 </a:solidFill>
                 <a:latin typeface="Calibri"/>
               </a:rPr>
-              <a:t>8B vs lite — what people actually get</a:t>
+              <a:t>9B vs lite — what people actually get</a:t>
             </a:r>
           </a:p>
         </p:txBody>
@@ -6009,7 +5927,7 @@
                           </a:solidFill>
                           <a:latin typeface="Calibri"/>
                         </a:rPr>
-                        <a:t>tantular-office (8B)</a:t>
+                        <a:t>tantular-office (9B)</a:t>
                       </a:r>
                     </a:p>
                   </a:txBody>
@@ -6092,7 +6010,7 @@
                           </a:solidFill>
                           <a:latin typeface="Calibri"/>
                         </a:rPr>
-                        <a:t>~5 GB</a:t>
+                        <a:t>~6.6 GB</a:t>
                       </a:r>
                     </a:p>
                   </a:txBody>
@@ -6119,7 +6037,7 @@
                           </a:solidFill>
                           <a:latin typeface="Calibri"/>
                         </a:rPr>
-                        <a:t>~2.5 GB</a:t>
+                        <a:t>~3.4 GB</a:t>
                       </a:r>
                     </a:p>
                   </a:txBody>
@@ -6397,7 +6315,7 @@
                           </a:solidFill>
                           <a:latin typeface="Calibri"/>
                         </a:rPr>
-                        <a:t>Risk of 5-minute timeouts</a:t>
+                        <a:t>Risk of Studio timeouts</a:t>
                       </a:r>
                     </a:p>
                   </a:txBody>
@@ -6503,7 +6421,7 @@
                 </a:solidFill>
                 <a:latin typeface="Calibri"/>
               </a:rPr>
-              <a:t>Deck quality on 4B is a step below 8B but still produces properly structured decks — vastly better than timeouts and fallbacks.</a:t>
+              <a:t>Deck quality on 4B is a step below 9B but still produces properly structured decks — vastly better than timeouts and fallbacks.</a:t>
             </a:r>
           </a:p>
         </p:txBody>
@@ -6695,7 +6613,7 @@
                 </a:solidFill>
                 <a:latin typeface="Calibri"/>
               </a:rPr>
-              <a:t>16 GB RAM → full 8B experience.  8 GB RAM → lite model, still works. Below 12 GB the installer automatically switches to tantular-office:lite.</a:t>
+              <a:t>16 GB RAM → full 9B experience.  8 GB RAM → lite model, still works. Below 12 GB the installer automatically switches to tantular-office:lite.</a:t>
             </a:r>
           </a:p>
         </p:txBody>

</xml_diff>